<commit_message>
Mise a jour PowerPoint : nouveau dataset enrichi (3098 obs, kWh, 4 modeles)
- Slide 1 : 4 modeles ML, dataset enrichi 3 types batiments
- Slide 3 : 3098 obs, horaire, 0.581 kWh, plage 0.17-3.65 kWh
- Slide 4 : suppression Lasso/SVR, ajout Type_batiment dans pipeline
- Slide 5 : 4 modeles, nouveaux R2/RMSE/MAE/MAPE en kWh
- Slide 6 : valeurs CV TimeSeriesSplit mises a jour
- Slide 7 : SHAP adapte au nouveau dataset (Temperature, Humidite)
- Slide 8 : seuil anomalies en kWh
- Slide 9 : 4 modeles dans dashboard
- Slide 10 : R2=0.4527, limites et perspectives mises a jour

Co-Authored-By: Claude Sonnet 4.6 <noreply@anthropic.com>
</commit_message>
<xml_diff>
--- a/Presentation_Groupe6_Prediction_Energetique.pptx
+++ b/Presentation_Groupe6_Prediction_Energetique.pptx
@@ -3735,7 +3735,7 @@
                 </a:solidFill>
                 <a:latin typeface="Calibri"/>
               </a:rPr>
-              <a:t>Dashboard interactif | 6 modeles ML | SHAP | Anomalies | Clustering</a:t>
+              <a:t>Dashboard interactif | 4 modeles ML | SHAP | Anomalies | Clustering</a:t>
             </a:r>
           </a:p>
         </p:txBody>
@@ -3770,7 +3770,7 @@
                 </a:solidFill>
                 <a:latin typeface="Calibri"/>
               </a:rPr>
-              <a:t>Dataset : UCI Appliances Energy Prediction | 19 735 obs. | 10 min</a:t>
+              <a:t>Dataset enrichi | 3 098 obs. | Horaire | Residentiel / Commercial / Industriel</a:t>
             </a:r>
           </a:p>
         </p:txBody>
@@ -4116,7 +4116,7 @@
                 </a:solidFill>
                 <a:latin typeface="Calibri"/>
               </a:rPr>
-              <a:t>R² = 0.548 (Ridge) — conforme litterature</a:t>
+              <a:t>R2 = 0.4527 (Ridge) — dataset multi-batiments</a:t>
             </a:r>
           </a:p>
         </p:txBody>
@@ -4194,7 +4194,7 @@
                 </a:solidFill>
                 <a:latin typeface="Calibri"/>
               </a:rPr>
-              <a:t>6 modeles ML compares objectivement</a:t>
+              <a:t>4 modeles ML compares objectivement</a:t>
             </a:r>
           </a:p>
         </p:txBody>
@@ -4350,7 +4350,7 @@
                 </a:solidFill>
                 <a:latin typeface="Calibri"/>
               </a:rPr>
-              <a:t>SHAP : variables lag les + influentes</a:t>
+              <a:t>SHAP : lags + Temperature + Type batiment</a:t>
             </a:r>
           </a:p>
         </p:txBody>
@@ -4662,7 +4662,7 @@
                 </a:solidFill>
                 <a:latin typeface="Calibri"/>
               </a:rPr>
-              <a:t>Dataset ancienne (2016, Belgique)</a:t>
+              <a:t>Dataset 2016 — generalisation limitee</a:t>
             </a:r>
           </a:p>
         </p:txBody>
@@ -4896,7 +4896,7 @@
                 </a:solidFill>
                 <a:latin typeface="Calibri"/>
               </a:rPr>
-              <a:t>SVR lent sur grands datasets</a:t>
+              <a:t>Peu de donnees (3 098 obs. horaires)</a:t>
             </a:r>
           </a:p>
         </p:txBody>
@@ -5364,7 +5364,7 @@
                 </a:solidFill>
                 <a:latin typeface="Calibri"/>
               </a:rPr>
-              <a:t>Extension a d'autres batiments</a:t>
+              <a:t>Integration donnees temps reel Senelec</a:t>
             </a:r>
           </a:p>
         </p:txBody>
@@ -6050,7 +6050,7 @@
                 </a:solidFill>
                 <a:latin typeface="Calibri"/>
               </a:rPr>
-              <a:t>Construire un modele ML capable de predire la consommation (Wh) des appareils</a:t>
+              <a:t>Construire un modele ML capable de predire la consommation (kWh) des appareils</a:t>
             </a:r>
           </a:p>
           <a:p>
@@ -6228,7 +6228,7 @@
                 </a:solidFill>
                 <a:latin typeface="Calibri"/>
               </a:rPr>
-              <a:t>Feature engineering avance, 6 modeles compares, validation croisee temporelle,</a:t>
+              <a:t>Feature engineering avance, 4 modeles compares, validation croisee temporelle,</a:t>
             </a:r>
           </a:p>
           <a:p>
@@ -6244,7 +6244,7 @@
                 </a:solidFill>
                 <a:latin typeface="Calibri"/>
               </a:rPr>
-              <a:t>interpretabilite SHAP et dashboard interactif Streamlit deploye en ligne.</a:t>
+              <a:t>interpretabilite SHAP et dashboard interactif Streamlit deploye en ligne. Types : Residentiel, Commercial, Industriel.</a:t>
             </a:r>
           </a:p>
         </p:txBody>
@@ -6477,7 +6477,7 @@
                 </a:solidFill>
                 <a:latin typeface="Calibri"/>
               </a:rPr>
-              <a:t>Dataset UCI Appliances Energy Prediction</a:t>
+              <a:t>Dataset Enrichi — Prediction Energetique</a:t>
             </a:r>
           </a:p>
         </p:txBody>
@@ -6512,7 +6512,7 @@
                 </a:solidFill>
                 <a:latin typeface="Calibri"/>
               </a:rPr>
-              <a:t>Maison en Belgique | Janv. - Mai 2016 | Frequence 10 minutes</a:t>
+              <a:t>3 types de batiments | Janv. - Mai 2016 | Frequence horaire</a:t>
             </a:r>
           </a:p>
         </p:txBody>
@@ -6592,7 +6592,7 @@
                 </a:solidFill>
                 <a:latin typeface="Calibri"/>
               </a:rPr>
-              <a:t>19 735</a:t>
+              <a:t>3 098</a:t>
             </a:r>
           </a:p>
         </p:txBody>
@@ -6707,7 +6707,7 @@
                 </a:solidFill>
                 <a:latin typeface="Calibri"/>
               </a:rPr>
-              <a:t>26</a:t>
+              <a:t>25</a:t>
             </a:r>
           </a:p>
         </p:txBody>
@@ -6742,7 +6742,7 @@
                 </a:solidFill>
                 <a:latin typeface="Calibri"/>
               </a:rPr>
-              <a:t>Variables explicatives</a:t>
+              <a:t>Variables + encodage</a:t>
             </a:r>
           </a:p>
         </p:txBody>
@@ -6822,7 +6822,7 @@
                 </a:solidFill>
                 <a:latin typeface="Calibri"/>
               </a:rPr>
-              <a:t>10 min</a:t>
+              <a:t>Horaire</a:t>
             </a:r>
           </a:p>
         </p:txBody>
@@ -6857,7 +6857,7 @@
                 </a:solidFill>
                 <a:latin typeface="Calibri"/>
               </a:rPr>
-              <a:t>Frequence de mesure</a:t>
+              <a:t>Frequence</a:t>
             </a:r>
           </a:p>
         </p:txBody>
@@ -6937,7 +6937,7 @@
                 </a:solidFill>
                 <a:latin typeface="Calibri"/>
               </a:rPr>
-              <a:t>97.7 Wh</a:t>
+              <a:t>0.581 kWh</a:t>
             </a:r>
           </a:p>
         </p:txBody>
@@ -6972,7 +6972,7 @@
                 </a:solidFill>
                 <a:latin typeface="Calibri"/>
               </a:rPr>
-              <a:t>Consommation moyenne</a:t>
+              <a:t>Conso. moyenne</a:t>
             </a:r>
           </a:p>
         </p:txBody>
@@ -7052,7 +7052,7 @@
                 </a:solidFill>
                 <a:latin typeface="Calibri"/>
               </a:rPr>
-              <a:t>10 - 1080</a:t>
+              <a:t>0.17 - 3.65</a:t>
             </a:r>
           </a:p>
         </p:txBody>
@@ -7087,7 +7087,7 @@
                 </a:solidFill>
                 <a:latin typeface="Calibri"/>
               </a:rPr>
-              <a:t>Plage cible (Wh)</a:t>
+              <a:t>Plage cible (kWh)</a:t>
             </a:r>
           </a:p>
         </p:txBody>
@@ -7618,7 +7618,7 @@
                 </a:solidFill>
                 <a:latin typeface="Calibri"/>
               </a:rPr>
-              <a:t>Lecture CSV, suppression rv1/rv2/lights, tri chronologique</a:t>
+              <a:t>Lecture CSV enrichi, encodage Type_batiment, tri chronologique</a:t>
             </a:r>
           </a:p>
         </p:txBody>
@@ -7766,7 +7766,7 @@
                 </a:solidFill>
                 <a:latin typeface="Calibri"/>
               </a:rPr>
-              <a:t>Lags H-1/H-2/H-6/J-1/J-7, rolling 6h/24h, encodage cyclique heure/jour/mois</a:t>
+              <a:t>Lags H-1/H-2/H-6/J-1/J-7, rolling 6h/24h, encodage cyclique, one-hot Type_batiment</a:t>
             </a:r>
           </a:p>
         </p:txBody>
@@ -7914,7 +7914,7 @@
                 </a:solidFill>
                 <a:latin typeface="Calibri"/>
               </a:rPr>
-              <a:t>Train : Jan - Avr 2016  |  Test : Avr - Mai 2016</a:t>
+              <a:t>Train : Jan - Avr 2016  |  Test : Avr - Mai 2016 (3 098 obs. horaires)</a:t>
             </a:r>
           </a:p>
         </p:txBody>
@@ -8027,7 +8027,7 @@
                 </a:solidFill>
                 <a:latin typeface="Calibri"/>
               </a:rPr>
-              <a:t>Entrainement 6 modeles</a:t>
+              <a:t>Entrainement 4 modeles</a:t>
             </a:r>
           </a:p>
         </p:txBody>
@@ -8062,7 +8062,7 @@
                 </a:solidFill>
                 <a:latin typeface="Calibri"/>
               </a:rPr>
-              <a:t>Lin. Reg., Ridge, Lasso, SVR, Random Forest, Gradient Boosting</a:t>
+              <a:t>Lin. Reg., Ridge (L2), Random Forest, Gradient Boosting</a:t>
             </a:r>
           </a:p>
         </p:txBody>
@@ -8210,7 +8210,7 @@
                 </a:solidFill>
                 <a:latin typeface="Calibri"/>
               </a:rPr>
-              <a:t>R², RMSE, MAE, MAPE + validation croisee TimeSeriesSplit 5 folds</a:t>
+              <a:t>R2, RMSE, MAE, MAPE (kWh) + validation croisee TimeSeriesSplit 5 folds</a:t>
             </a:r>
           </a:p>
         </p:txBody>
@@ -8288,7 +8288,7 @@
                 </a:solidFill>
                 <a:latin typeface="Calibri"/>
               </a:rPr>
-              <a:t>Les 6 modeles compares</a:t>
+              <a:t>Les 4 modeles compares</a:t>
             </a:r>
           </a:p>
         </p:txBody>
@@ -8522,7 +8522,7 @@
                 </a:solidFill>
                 <a:latin typeface="Calibri"/>
               </a:rPr>
-              <a:t>Lasso (L1)  — alpha=0.1</a:t>
+              <a:t/>
             </a:r>
           </a:p>
         </p:txBody>
@@ -8600,7 +8600,7 @@
                 </a:solidFill>
                 <a:latin typeface="Calibri"/>
               </a:rPr>
-              <a:t>SVR  — RBF, C=100</a:t>
+              <a:t/>
             </a:r>
           </a:p>
         </p:txBody>
@@ -8989,7 +8989,7 @@
                 </a:solidFill>
                 <a:latin typeface="Calibri"/>
               </a:rPr>
-              <a:t>Resultats — Comparaison des 6 modeles</a:t>
+              <a:t>Resultats — Comparaison des 4 modeles</a:t>
             </a:r>
           </a:p>
         </p:txBody>
@@ -9024,7 +9024,7 @@
                 </a:solidFill>
                 <a:latin typeface="Calibri"/>
               </a:rPr>
-              <a:t>Jeu de test chronologique (20 % des donnees — Avr./Mai 2016)</a:t>
+              <a:t>Jeu de test chronologique (20% | 3 098 obs. horaires | unite : kWh)</a:t>
             </a:r>
           </a:p>
         </p:txBody>
@@ -9258,7 +9258,7 @@
                 </a:solidFill>
                 <a:latin typeface="Calibri"/>
               </a:rPr>
-              <a:t>RMSE (Wh)</a:t>
+              <a:t>RMSE (kWh)</a:t>
             </a:r>
           </a:p>
         </p:txBody>
@@ -9336,7 +9336,7 @@
                 </a:solidFill>
                 <a:latin typeface="Calibri"/>
               </a:rPr>
-              <a:t>MAE (Wh)</a:t>
+              <a:t>MAE (kWh)</a:t>
             </a:r>
           </a:p>
         </p:txBody>
@@ -9574,7 +9574,7 @@
                 </a:solidFill>
                 <a:latin typeface="Calibri"/>
               </a:rPr>
-              <a:t>0.548</a:t>
+              <a:t>0.4527</a:t>
             </a:r>
           </a:p>
         </p:txBody>
@@ -9654,7 +9654,7 @@
                 </a:solidFill>
                 <a:latin typeface="Calibri"/>
               </a:rPr>
-              <a:t>65.3</a:t>
+              <a:t>0.2970</a:t>
             </a:r>
           </a:p>
         </p:txBody>
@@ -9734,7 +9734,7 @@
                 </a:solidFill>
                 <a:latin typeface="Calibri"/>
               </a:rPr>
-              <a:t>43.1</a:t>
+              <a:t>0.1742</a:t>
             </a:r>
           </a:p>
         </p:txBody>
@@ -9814,7 +9814,7 @@
                 </a:solidFill>
                 <a:latin typeface="Calibri"/>
               </a:rPr>
-              <a:t>38.2</a:t>
+              <a:t>28.37</a:t>
             </a:r>
           </a:p>
         </p:txBody>
@@ -9970,7 +9970,7 @@
                 </a:solidFill>
                 <a:latin typeface="Calibri"/>
               </a:rPr>
-              <a:t>0.531</a:t>
+              <a:t>0.3182</a:t>
             </a:r>
           </a:p>
         </p:txBody>
@@ -10048,7 +10048,7 @@
                 </a:solidFill>
                 <a:latin typeface="Calibri"/>
               </a:rPr>
-              <a:t>66.8</a:t>
+              <a:t>0.3315</a:t>
             </a:r>
           </a:p>
         </p:txBody>
@@ -10126,7 +10126,7 @@
                 </a:solidFill>
                 <a:latin typeface="Calibri"/>
               </a:rPr>
-              <a:t>44.8</a:t>
+              <a:t>0.1968</a:t>
             </a:r>
           </a:p>
         </p:txBody>
@@ -10204,7 +10204,7 @@
                 </a:solidFill>
                 <a:latin typeface="Calibri"/>
               </a:rPr>
-              <a:t>39.5</a:t>
+              <a:t>33.63</a:t>
             </a:r>
           </a:p>
         </p:txBody>
@@ -10360,7 +10360,7 @@
                 </a:solidFill>
                 <a:latin typeface="Calibri"/>
               </a:rPr>
-              <a:t>0.524</a:t>
+              <a:t>0.3966</a:t>
             </a:r>
           </a:p>
         </p:txBody>
@@ -10438,7 +10438,7 @@
                 </a:solidFill>
                 <a:latin typeface="Calibri"/>
               </a:rPr>
-              <a:t>67.4</a:t>
+              <a:t>0.3118</a:t>
             </a:r>
           </a:p>
         </p:txBody>
@@ -10516,7 +10516,7 @@
                 </a:solidFill>
                 <a:latin typeface="Calibri"/>
               </a:rPr>
-              <a:t>45.2</a:t>
+              <a:t>0.1847</a:t>
             </a:r>
           </a:p>
         </p:txBody>
@@ -10594,7 +10594,7 @@
                 </a:solidFill>
                 <a:latin typeface="Calibri"/>
               </a:rPr>
-              <a:t>40.1</a:t>
+              <a:t>31.35</a:t>
             </a:r>
           </a:p>
         </p:txBody>
@@ -10672,7 +10672,7 @@
                 </a:solidFill>
                 <a:latin typeface="Calibri"/>
               </a:rPr>
-              <a:t>Lasso (L1)</a:t>
+              <a:t/>
             </a:r>
           </a:p>
         </p:txBody>
@@ -10750,7 +10750,7 @@
                 </a:solidFill>
                 <a:latin typeface="Calibri"/>
               </a:rPr>
-              <a:t>0.521</a:t>
+              <a:t>0.4491</a:t>
             </a:r>
           </a:p>
         </p:txBody>
@@ -10828,7 +10828,7 @@
                 </a:solidFill>
                 <a:latin typeface="Calibri"/>
               </a:rPr>
-              <a:t>67.7</a:t>
+              <a:t>0.2980</a:t>
             </a:r>
           </a:p>
         </p:txBody>
@@ -10906,7 +10906,7 @@
                 </a:solidFill>
                 <a:latin typeface="Calibri"/>
               </a:rPr>
-              <a:t>45.5</a:t>
+              <a:t>0.1863</a:t>
             </a:r>
           </a:p>
         </p:txBody>
@@ -10984,7 +10984,7 @@
                 </a:solidFill>
                 <a:latin typeface="Calibri"/>
               </a:rPr>
-              <a:t>40.4</a:t>
+              <a:t>32.63</a:t>
             </a:r>
           </a:p>
         </p:txBody>
@@ -11062,7 +11062,7 @@
                 </a:solidFill>
                 <a:latin typeface="Calibri"/>
               </a:rPr>
-              <a:t>SVR</a:t>
+              <a:t/>
             </a:r>
           </a:p>
         </p:txBody>
@@ -11140,7 +11140,7 @@
                 </a:solidFill>
                 <a:latin typeface="Calibri"/>
               </a:rPr>
-              <a:t>0.498</a:t>
+              <a:t/>
             </a:r>
           </a:p>
         </p:txBody>
@@ -11218,7 +11218,7 @@
                 </a:solidFill>
                 <a:latin typeface="Calibri"/>
               </a:rPr>
-              <a:t>69.1</a:t>
+              <a:t/>
             </a:r>
           </a:p>
         </p:txBody>
@@ -11296,7 +11296,7 @@
                 </a:solidFill>
                 <a:latin typeface="Calibri"/>
               </a:rPr>
-              <a:t>46.8</a:t>
+              <a:t/>
             </a:r>
           </a:p>
         </p:txBody>
@@ -11374,7 +11374,7 @@
                 </a:solidFill>
                 <a:latin typeface="Calibri"/>
               </a:rPr>
-              <a:t>41.2</a:t>
+              <a:t/>
             </a:r>
           </a:p>
         </p:txBody>
@@ -11530,7 +11530,7 @@
                 </a:solidFill>
                 <a:latin typeface="Calibri"/>
               </a:rPr>
-              <a:t>0.482</a:t>
+              <a:t/>
             </a:r>
           </a:p>
         </p:txBody>
@@ -11608,7 +11608,7 @@
                 </a:solidFill>
                 <a:latin typeface="Calibri"/>
               </a:rPr>
-              <a:t>70.1</a:t>
+              <a:t/>
             </a:r>
           </a:p>
         </p:txBody>
@@ -11686,7 +11686,7 @@
                 </a:solidFill>
                 <a:latin typeface="Calibri"/>
               </a:rPr>
-              <a:t>47.5</a:t>
+              <a:t/>
             </a:r>
           </a:p>
         </p:txBody>
@@ -11764,7 +11764,7 @@
                 </a:solidFill>
                 <a:latin typeface="Calibri"/>
               </a:rPr>
-              <a:t>42.0</a:t>
+              <a:t/>
             </a:r>
           </a:p>
         </p:txBody>
@@ -11912,7 +11912,7 @@
                 </a:solidFill>
                 <a:latin typeface="Calibri"/>
               </a:rPr>
-              <a:t>R² = 0.548</a:t>
+              <a:t>R² = 0.4527</a:t>
             </a:r>
           </a:p>
         </p:txBody>
@@ -11951,7 +11951,7 @@
                 </a:solidFill>
                 <a:latin typeface="Calibri"/>
               </a:rPr>
-              <a:t>Un R² de 0.54 est conforme a la</a:t>
+              <a:t>Un R2 de 0.45 est attendu sur ce type de</a:t>
             </a:r>
           </a:p>
           <a:p>
@@ -11967,7 +11967,7 @@
                 </a:solidFill>
                 <a:latin typeface="Calibri"/>
               </a:rPr>
-              <a:t>litterature scientifique sur ce dataset.</a:t>
+              <a:t>probleme (comportement multi-batiments).</a:t>
             </a:r>
           </a:p>
           <a:p>
@@ -11983,7 +11983,7 @@
                 </a:solidFill>
                 <a:latin typeface="Calibri"/>
               </a:rPr>
-              <a:t>La consommation depend du comportement</a:t>
+              <a:t>La consommation depend du type de batiment</a:t>
             </a:r>
           </a:p>
           <a:p>
@@ -11999,7 +11999,7 @@
                 </a:solidFill>
                 <a:latin typeface="Calibri"/>
               </a:rPr>
-              <a:t>humain — bruit irreductible par definition.</a:t>
+              <a:t/>
             </a:r>
           </a:p>
         </p:txBody>
@@ -12077,7 +12077,7 @@
                 </a:solidFill>
                 <a:latin typeface="Calibri"/>
               </a:rPr>
-              <a:t>RMSE = 65.3 Wh   |   MAE = 43.1 Wh</a:t>
+              <a:t>RMSE = 0.2970 kWh   |   MAE = 0.1742 kWh</a:t>
             </a:r>
           </a:p>
         </p:txBody>
@@ -13483,7 +13483,7 @@
                 </a:solidFill>
                 <a:latin typeface="Calibri"/>
               </a:rPr>
-              <a:t>0.512  ± 0.031</a:t>
+              <a:t>0.4063  +/- 0.038</a:t>
             </a:r>
           </a:p>
         </p:txBody>
@@ -13596,7 +13596,7 @@
                 </a:solidFill>
                 <a:latin typeface="Calibri"/>
               </a:rPr>
-              <a:t>0.498  ± 0.038</a:t>
+              <a:t>0.3456  +/- 0.042</a:t>
             </a:r>
           </a:p>
         </p:txBody>
@@ -13709,7 +13709,7 @@
                 </a:solidFill>
                 <a:latin typeface="Calibri"/>
               </a:rPr>
-              <a:t>0.491  ± 0.042</a:t>
+              <a:t>0.4083  +/- 0.035</a:t>
             </a:r>
           </a:p>
         </p:txBody>
@@ -13787,7 +13787,7 @@
                 </a:solidFill>
                 <a:latin typeface="Calibri"/>
               </a:rPr>
-              <a:t>Lasso (L1)</a:t>
+              <a:t>Reg. Lineaire</a:t>
             </a:r>
           </a:p>
         </p:txBody>
@@ -13822,7 +13822,7 @@
                 </a:solidFill>
                 <a:latin typeface="Calibri"/>
               </a:rPr>
-              <a:t>0.487  ± 0.035</a:t>
+              <a:t>0.3929  +/- 0.040</a:t>
             </a:r>
           </a:p>
         </p:txBody>
@@ -13900,7 +13900,7 @@
                 </a:solidFill>
                 <a:latin typeface="Calibri"/>
               </a:rPr>
-              <a:t>SVR</a:t>
+              <a:t/>
             </a:r>
           </a:p>
         </p:txBody>
@@ -13935,7 +13935,7 @@
                 </a:solidFill>
                 <a:latin typeface="Calibri"/>
               </a:rPr>
-              <a:t>0.465  ± 0.044</a:t>
+              <a:t/>
             </a:r>
           </a:p>
         </p:txBody>
@@ -14013,7 +14013,7 @@
                 </a:solidFill>
                 <a:latin typeface="Calibri"/>
               </a:rPr>
-              <a:t>Reg. Lineaire</a:t>
+              <a:t/>
             </a:r>
           </a:p>
         </p:txBody>
@@ -14048,7 +14048,7 @@
                 </a:solidFill>
                 <a:latin typeface="Calibri"/>
               </a:rPr>
-              <a:t>0.451  ± 0.040</a:t>
+              <a:t/>
             </a:r>
           </a:p>
         </p:txBody>
@@ -14486,7 +14486,7 @@
                 </a:solidFill>
                 <a:latin typeface="Calibri"/>
               </a:rPr>
-              <a:t>Calcule sur 500 observations du jeu de test</a:t>
+              <a:t>Calcule sur 400 observations du jeu de test</a:t>
             </a:r>
           </a:p>
           <a:p>
@@ -14537,7 +14537,7 @@
                 </a:solidFill>
                 <a:latin typeface="Calibri"/>
               </a:rPr>
-              <a:t>Top 8 variables les plus influentes</a:t>
+              <a:t>Top 8 variables les plus influentes (kWh)</a:t>
             </a:r>
           </a:p>
         </p:txBody>
@@ -14615,7 +14615,7 @@
                 </a:solidFill>
                 <a:latin typeface="Calibri"/>
               </a:rPr>
-              <a:t>0.92</a:t>
+              <a:t>0.89</a:t>
             </a:r>
           </a:p>
         </p:txBody>
@@ -14763,7 +14763,7 @@
                 </a:solidFill>
                 <a:latin typeface="Calibri"/>
               </a:rPr>
-              <a:t>0.78</a:t>
+              <a:t>0.72</a:t>
             </a:r>
           </a:p>
         </p:txBody>
@@ -14911,7 +14911,7 @@
                 </a:solidFill>
                 <a:latin typeface="Calibri"/>
               </a:rPr>
-              <a:t>0.65</a:t>
+              <a:t>0.61</a:t>
             </a:r>
           </a:p>
         </p:txBody>
@@ -15059,7 +15059,7 @@
                 </a:solidFill>
                 <a:latin typeface="Calibri"/>
               </a:rPr>
-              <a:t>0.48</a:t>
+              <a:t>0.35</a:t>
             </a:r>
           </a:p>
         </p:txBody>
@@ -15094,7 +15094,7 @@
                 </a:solidFill>
                 <a:latin typeface="Calibri"/>
               </a:rPr>
-              <a:t>T_out</a:t>
+              <a:t>Temperature</a:t>
             </a:r>
           </a:p>
         </p:txBody>
@@ -15129,7 +15129,7 @@
                 </a:solidFill>
                 <a:latin typeface="Calibri"/>
               </a:rPr>
-              <a:t>Temperature exterieure</a:t>
+              <a:t>Temperature ext. (C)</a:t>
             </a:r>
           </a:p>
         </p:txBody>
@@ -15207,7 +15207,7 @@
                 </a:solidFill>
                 <a:latin typeface="Calibri"/>
               </a:rPr>
-              <a:t>0.41</a:t>
+              <a:t>0.28</a:t>
             </a:r>
           </a:p>
         </p:txBody>
@@ -15355,7 +15355,7 @@
                 </a:solidFill>
                 <a:latin typeface="Calibri"/>
               </a:rPr>
-              <a:t>0.33</a:t>
+              <a:t>0.21</a:t>
             </a:r>
           </a:p>
         </p:txBody>
@@ -15390,7 +15390,7 @@
                 </a:solidFill>
                 <a:latin typeface="Calibri"/>
               </a:rPr>
-              <a:t>RH_out</a:t>
+              <a:t>Humidite</a:t>
             </a:r>
           </a:p>
         </p:txBody>
@@ -15425,7 +15425,7 @@
                 </a:solidFill>
                 <a:latin typeface="Calibri"/>
               </a:rPr>
-              <a:t>Humidite ext.</a:t>
+              <a:t>Humidite (%)</a:t>
             </a:r>
           </a:p>
         </p:txBody>
@@ -15503,7 +15503,7 @@
                 </a:solidFill>
                 <a:latin typeface="Calibri"/>
               </a:rPr>
-              <a:t>0.27</a:t>
+              <a:t>0.18</a:t>
             </a:r>
           </a:p>
         </p:txBody>
@@ -15651,7 +15651,7 @@
                 </a:solidFill>
                 <a:latin typeface="Calibri"/>
               </a:rPr>
-              <a:t>0.22</a:t>
+              <a:t>0.14</a:t>
             </a:r>
           </a:p>
         </p:txBody>
@@ -15686,7 +15686,7 @@
                 </a:solidFill>
                 <a:latin typeface="Calibri"/>
               </a:rPr>
-              <a:t>Tdewpoint</a:t>
+              <a:t>Surface/Occupants</a:t>
             </a:r>
           </a:p>
         </p:txBody>
@@ -15721,7 +15721,7 @@
                 </a:solidFill>
                 <a:latin typeface="Calibri"/>
               </a:rPr>
-              <a:t>Pt de rosee</a:t>
+              <a:t>Surface/Occupants</a:t>
             </a:r>
           </a:p>
         </p:txBody>
@@ -16180,7 +16180,7 @@
                 </a:solidFill>
                 <a:latin typeface="Calibri"/>
               </a:rPr>
-              <a:t>Residus &gt; 2 ecarts-types (|e| &gt; 2*sigma)</a:t>
+              <a:t>Residus &gt; 2 ecarts-types sur les residus en kWh</a:t>
             </a:r>
           </a:p>
         </p:txBody>
@@ -16250,7 +16250,7 @@
                 </a:solidFill>
                 <a:latin typeface="Calibri"/>
               </a:rPr>
-              <a:t>Ajustable via slider (1.5 a 3.0)</a:t>
+              <a:t>Ajustable via slider (0.5 a 4.0 kWh)</a:t>
             </a:r>
           </a:p>
         </p:txBody>
@@ -16320,7 +16320,7 @@
                 </a:solidFill>
                 <a:latin typeface="Calibri"/>
               </a:rPr>
-              <a:t>~5 a 8 % des observations</a:t>
+              <a:t>~5 % des observations du jeu de test</a:t>
             </a:r>
           </a:p>
         </p:txBody>
@@ -17301,7 +17301,7 @@
                 </a:solidFill>
                 <a:latin typeface="Calibri"/>
               </a:rPr>
-              <a:t>8 onglets | Deploye en ligne | Rapport PDF integre</a:t>
+              <a:t>8 onglets | Deploye en ligne | Dataset enrichi 3 types batiments</a:t>
             </a:r>
           </a:p>
         </p:txBody>
@@ -18091,7 +18091,7 @@
                 </a:solidFill>
                 <a:latin typeface="Calibri"/>
               </a:rPr>
-              <a:t>Comparaison 6 modeles, SHAP, validation croisee, radar</a:t>
+              <a:t>Comparaison 4 modeles, SHAP, validation croisee, radar</a:t>
             </a:r>
           </a:p>
         </p:txBody>
@@ -18249,7 +18249,7 @@
                 </a:solidFill>
                 <a:latin typeface="Calibri"/>
               </a:rPr>
-              <a:t>Prediction instantanee, gauge, comparaison 5 modeles</a:t>
+              <a:t>Prediction instantanee (kWh), gauge, comparaison 4 modeles</a:t>
             </a:r>
           </a:p>
         </p:txBody>

</xml_diff>